<commit_message>
minor change to several slides
</commit_message>
<xml_diff>
--- a/PowerPoints/09 - Constraint Analysis.pptx
+++ b/PowerPoints/09 - Constraint Analysis.pptx
@@ -26,8 +26,8 @@
     <p:sldId id="295" r:id="rId14"/>
     <p:sldId id="276" r:id="rId15"/>
     <p:sldId id="268" r:id="rId16"/>
-    <p:sldId id="364" r:id="rId17"/>
-    <p:sldId id="283" r:id="rId18"/>
+    <p:sldId id="283" r:id="rId17"/>
+    <p:sldId id="364" r:id="rId18"/>
     <p:sldId id="284" r:id="rId19"/>
     <p:sldId id="280" r:id="rId20"/>
     <p:sldId id="363" r:id="rId21"/>
@@ -1624,7 +1624,13 @@
   <p:cSld>
     <p:spTree>
       <p:nvGrpSpPr>
-        <p:cNvPr id="1" name=""/>
+        <p:cNvPr id="1" name="">
+          <a:extLst>
+            <a:ext uri="{FF2B5EF4-FFF2-40B4-BE49-F238E27FC236}">
+              <a16:creationId xmlns:a16="http://schemas.microsoft.com/office/drawing/2014/main" id="{81780ED1-B738-23A3-7A69-8A77CE780A6A}"/>
+            </a:ext>
+          </a:extLst>
+        </p:cNvPr>
         <p:cNvGrpSpPr/>
         <p:nvPr/>
       </p:nvGrpSpPr>
@@ -1638,7 +1644,13 @@
       </p:grpSpPr>
       <p:sp>
         <p:nvSpPr>
-          <p:cNvPr id="36866" name="Slide Image Placeholder 1"/>
+          <p:cNvPr id="36866" name="Slide Image Placeholder 1">
+            <a:extLst>
+              <a:ext uri="{FF2B5EF4-FFF2-40B4-BE49-F238E27FC236}">
+                <a16:creationId xmlns:a16="http://schemas.microsoft.com/office/drawing/2014/main" id="{755F65FA-47BC-4461-0DB5-959C2015FD42}"/>
+              </a:ext>
+            </a:extLst>
+          </p:cNvPr>
           <p:cNvSpPr>
             <a:spLocks noGrp="1" noRot="1" noChangeAspect="1" noTextEdit="1"/>
           </p:cNvSpPr>
@@ -1652,7 +1664,13 @@
       </p:sp>
       <p:sp>
         <p:nvSpPr>
-          <p:cNvPr id="36867" name="Notes Placeholder 2"/>
+          <p:cNvPr id="36867" name="Notes Placeholder 2">
+            <a:extLst>
+              <a:ext uri="{FF2B5EF4-FFF2-40B4-BE49-F238E27FC236}">
+                <a16:creationId xmlns:a16="http://schemas.microsoft.com/office/drawing/2014/main" id="{7D393023-2495-B6E5-BFE1-CCB21B057A41}"/>
+              </a:ext>
+            </a:extLst>
+          </p:cNvPr>
           <p:cNvSpPr>
             <a:spLocks noGrp="1"/>
           </p:cNvSpPr>
@@ -1674,7 +1692,13 @@
       </p:sp>
       <p:sp>
         <p:nvSpPr>
-          <p:cNvPr id="36868" name="Header Placeholder 3"/>
+          <p:cNvPr id="36868" name="Header Placeholder 3">
+            <a:extLst>
+              <a:ext uri="{FF2B5EF4-FFF2-40B4-BE49-F238E27FC236}">
+                <a16:creationId xmlns:a16="http://schemas.microsoft.com/office/drawing/2014/main" id="{40E4F28E-3944-25FF-BC42-0175565D3097}"/>
+              </a:ext>
+            </a:extLst>
+          </p:cNvPr>
           <p:cNvSpPr>
             <a:spLocks noGrp="1"/>
           </p:cNvSpPr>
@@ -1699,7 +1723,13 @@
       </p:sp>
       <p:sp>
         <p:nvSpPr>
-          <p:cNvPr id="36869" name="Slide Number Placeholder 4"/>
+          <p:cNvPr id="36869" name="Slide Number Placeholder 4">
+            <a:extLst>
+              <a:ext uri="{FF2B5EF4-FFF2-40B4-BE49-F238E27FC236}">
+                <a16:creationId xmlns:a16="http://schemas.microsoft.com/office/drawing/2014/main" id="{31A6BEAD-F25E-49CB-1E8A-3A50E9641781}"/>
+              </a:ext>
+            </a:extLst>
+          </p:cNvPr>
           <p:cNvSpPr>
             <a:spLocks noGrp="1"/>
           </p:cNvSpPr>
@@ -1727,7 +1757,7 @@
     </p:spTree>
     <p:extLst>
       <p:ext uri="{BB962C8B-B14F-4D97-AF65-F5344CB8AC3E}">
-        <p14:creationId xmlns:p14="http://schemas.microsoft.com/office/powerpoint/2010/main" val="582022513"/>
+        <p14:creationId xmlns:p14="http://schemas.microsoft.com/office/powerpoint/2010/main" val="1369254542"/>
       </p:ext>
     </p:extLst>
   </p:cSld>
@@ -6539,23 +6569,23 @@
           <a:p>
             <a:pPr lvl="2"/>
             <a:r>
-              <a:rPr lang="en-US" dirty="0"/>
-              <a:t> Use AST method </a:t>
-            </a:r>
-            <a:r>
-              <a:rPr lang="en-US" dirty="0" err="1">
+              <a:rPr lang="en-US" sz="1750" dirty="0"/>
+              <a:t>Use AST method </a:t>
+            </a:r>
+            <a:r>
+              <a:rPr lang="en-US" sz="1750" dirty="0" err="1">
                 <a:latin typeface="Consolas" panose="020B0609020204030204" pitchFamily="49" charset="0"/>
               </a:rPr>
               <a:t>matchTypes</a:t>
             </a:r>
             <a:r>
-              <a:rPr lang="en-US" dirty="0">
+              <a:rPr lang="en-US" sz="1750" dirty="0">
                 <a:latin typeface="Consolas" panose="020B0609020204030204" pitchFamily="49" charset="0"/>
               </a:rPr>
               <a:t>()</a:t>
             </a:r>
             <a:r>
-              <a:rPr lang="en-US" dirty="0"/>
+              <a:rPr lang="en-US" sz="1750" dirty="0"/>
               <a:t> to check assignment compatibility.</a:t>
             </a:r>
           </a:p>
@@ -6731,60 +6761,60 @@
           <a:p>
             <a:pPr lvl="2"/>
             <a:r>
-              <a:rPr lang="en-US" dirty="0"/>
-              <a:t>Object </a:t>
-            </a:r>
-            <a:r>
-              <a:rPr lang="en-US" dirty="0" err="1">
+              <a:rPr lang="en-US" sz="1750" dirty="0"/>
+              <a:t>Class </a:t>
+            </a:r>
+            <a:r>
+              <a:rPr lang="en-US" sz="1750" dirty="0" err="1">
                 <a:latin typeface="Consolas" panose="020B0609020204030204" pitchFamily="49" charset="0"/>
               </a:rPr>
               <a:t>IntUtil</a:t>
             </a:r>
             <a:r>
-              <a:rPr lang="en-US" dirty="0"/>
+              <a:rPr lang="en-US" sz="1750" dirty="0"/>
               <a:t> in package </a:t>
             </a:r>
             <a:r>
-              <a:rPr lang="en-US" dirty="0" err="1">
-                <a:latin typeface="Consolas" panose="020B0609020204030204" pitchFamily="49" charset="0"/>
-              </a:rPr>
-              <a:t>edu.citadel.common</a:t>
-            </a:r>
-            <a:r>
-              <a:rPr lang="en-US" dirty="0"/>
+              <a:rPr lang="en-US" sz="1750" dirty="0" err="1">
+                <a:latin typeface="Consolas" panose="020B0609020204030204" pitchFamily="49" charset="0"/>
+              </a:rPr>
+              <a:t>edu.citadel.common.util</a:t>
+            </a:r>
+            <a:r>
+              <a:rPr lang="en-US" sz="1750" dirty="0"/>
               <a:t> has a method named </a:t>
             </a:r>
             <a:r>
-              <a:rPr lang="en-US" dirty="0" err="1">
+              <a:rPr lang="en-US" sz="1750" dirty="0" err="1">
                 <a:latin typeface="Consolas" panose="020B0609020204030204" pitchFamily="49" charset="0"/>
               </a:rPr>
               <a:t>toInt</a:t>
             </a:r>
             <a:r>
-              <a:rPr lang="en-US" dirty="0">
+              <a:rPr lang="en-US" sz="1750" dirty="0">
                 <a:latin typeface="Consolas" panose="020B0609020204030204" pitchFamily="49" charset="0"/>
               </a:rPr>
               <a:t>()</a:t>
             </a:r>
             <a:r>
-              <a:rPr lang="en-US" dirty="0"/>
+              <a:rPr lang="en-US" sz="1750" dirty="0"/>
               <a:t> that can be used to check this.</a:t>
             </a:r>
           </a:p>
           <a:p>
             <a:pPr lvl="2"/>
             <a:r>
-              <a:rPr lang="en-US" dirty="0"/>
+              <a:rPr lang="en-US" sz="1750" dirty="0"/>
               <a:t>If the check fails, set the literal’s value to a valid value for type </a:t>
             </a:r>
             <a:r>
-              <a:rPr lang="en-US" dirty="0">
+              <a:rPr lang="en-US" sz="1750" dirty="0">
                 <a:latin typeface="Consolas" panose="020B0609020204030204" pitchFamily="49" charset="0"/>
               </a:rPr>
               <a:t>Integer</a:t>
             </a:r>
             <a:r>
-              <a:rPr lang="en-US" dirty="0"/>
+              <a:rPr lang="en-US" sz="1750" dirty="0"/>
               <a:t> in order to prevent additional error messages.</a:t>
             </a:r>
           </a:p>
@@ -6931,7 +6961,7 @@
         </p:nvSpPr>
         <p:spPr bwMode="auto">
           <a:xfrm>
-            <a:off x="1874146" y="5791200"/>
+            <a:off x="1874146" y="5724144"/>
             <a:ext cx="5395708" cy="400752"/>
           </a:xfrm>
           <a:prstGeom prst="rect">
@@ -7024,7 +7054,13 @@
   <p:cSld>
     <p:spTree>
       <p:nvGrpSpPr>
-        <p:cNvPr id="1" name=""/>
+        <p:cNvPr id="1" name="">
+          <a:extLst>
+            <a:ext uri="{FF2B5EF4-FFF2-40B4-BE49-F238E27FC236}">
+              <a16:creationId xmlns:a16="http://schemas.microsoft.com/office/drawing/2014/main" id="{BF1C0358-0359-8D1D-9A6D-6878C8F8590F}"/>
+            </a:ext>
+          </a:extLst>
+        </p:cNvPr>
         <p:cNvGrpSpPr/>
         <p:nvPr/>
       </p:nvGrpSpPr>
@@ -7038,7 +7074,13 @@
       </p:grpSpPr>
       <p:sp>
         <p:nvSpPr>
-          <p:cNvPr id="15362" name="Title 1"/>
+          <p:cNvPr id="15362" name="Title 1">
+            <a:extLst>
+              <a:ext uri="{FF2B5EF4-FFF2-40B4-BE49-F238E27FC236}">
+                <a16:creationId xmlns:a16="http://schemas.microsoft.com/office/drawing/2014/main" id="{E54F8F3C-6453-F057-29E9-0BFED1446C25}"/>
+              </a:ext>
+            </a:extLst>
+          </p:cNvPr>
           <p:cNvSpPr>
             <a:spLocks noGrp="1"/>
           </p:cNvSpPr>
@@ -7074,7 +7116,13 @@
       </p:sp>
       <p:sp>
         <p:nvSpPr>
-          <p:cNvPr id="15363" name="Content Placeholder 2"/>
+          <p:cNvPr id="15363" name="Content Placeholder 2">
+            <a:extLst>
+              <a:ext uri="{FF2B5EF4-FFF2-40B4-BE49-F238E27FC236}">
+                <a16:creationId xmlns:a16="http://schemas.microsoft.com/office/drawing/2014/main" id="{FFEA3EE0-4ED4-BCB3-A703-4F80F6388616}"/>
+              </a:ext>
+            </a:extLst>
+          </p:cNvPr>
           <p:cNvSpPr>
             <a:spLocks noGrp="1"/>
           </p:cNvSpPr>
@@ -7235,7 +7283,13 @@
       </p:sp>
       <p:sp>
         <p:nvSpPr>
-          <p:cNvPr id="15364" name="Footer Placeholder 3"/>
+          <p:cNvPr id="15364" name="Footer Placeholder 3">
+            <a:extLst>
+              <a:ext uri="{FF2B5EF4-FFF2-40B4-BE49-F238E27FC236}">
+                <a16:creationId xmlns:a16="http://schemas.microsoft.com/office/drawing/2014/main" id="{ECC2E413-0CCD-C824-4F6E-A260C343B09B}"/>
+              </a:ext>
+            </a:extLst>
+          </p:cNvPr>
           <p:cNvSpPr>
             <a:spLocks noGrp="1"/>
           </p:cNvSpPr>
@@ -7267,7 +7321,13 @@
       </p:sp>
       <p:sp>
         <p:nvSpPr>
-          <p:cNvPr id="15365" name="Slide Number Placeholder 4"/>
+          <p:cNvPr id="15365" name="Slide Number Placeholder 4">
+            <a:extLst>
+              <a:ext uri="{FF2B5EF4-FFF2-40B4-BE49-F238E27FC236}">
+                <a16:creationId xmlns:a16="http://schemas.microsoft.com/office/drawing/2014/main" id="{9ADB068F-823A-F7C7-834E-30DA4D972A9B}"/>
+              </a:ext>
+            </a:extLst>
+          </p:cNvPr>
           <p:cNvSpPr>
             <a:spLocks noGrp="1"/>
           </p:cNvSpPr>
@@ -7296,6 +7356,11 @@
         </p:txBody>
       </p:sp>
     </p:spTree>
+    <p:extLst>
+      <p:ext uri="{BB962C8B-B14F-4D97-AF65-F5344CB8AC3E}">
+        <p14:creationId xmlns:p14="http://schemas.microsoft.com/office/powerpoint/2010/main" val="3265024224"/>
+      </p:ext>
+    </p:extLst>
   </p:cSld>
   <p:clrMapOvr>
     <a:masterClrMapping/>
@@ -7495,35 +7560,58 @@
           </a:p>
           <a:p>
             <a:r>
-              <a:rPr lang="en-US" sz="2200" dirty="0">
-                <a:latin typeface="Consolas" panose="020B0609020204030204" pitchFamily="49" charset="0"/>
-              </a:rPr>
-              <a:t>Program</a:t>
-            </a:r>
+              <a:rPr lang="en-US" sz="2200" dirty="0" err="1">
+                <a:latin typeface="Consolas" panose="020B0609020204030204" pitchFamily="49" charset="0"/>
+              </a:rPr>
+              <a:t>OutputStmt</a:t>
+            </a:r>
+            <a:endParaRPr lang="en-US" sz="2200" dirty="0">
+              <a:latin typeface="Consolas" panose="020B0609020204030204" pitchFamily="49" charset="0"/>
+            </a:endParaRPr>
           </a:p>
           <a:p>
             <a:pPr lvl="1"/>
             <a:r>
               <a:rPr lang="en-US" sz="1900" dirty="0"/>
-              <a:t>Miscellaneous Rule: A program must contain a </a:t>
+              <a:t>Type Rule: Each expression must have type </a:t>
+            </a:r>
+            <a:r>
+              <a:rPr lang="en-US" sz="1900" dirty="0">
+                <a:latin typeface="Consolas" panose="020B0609020204030204" pitchFamily="49" charset="0"/>
+              </a:rPr>
+              <a:t>Integer</a:t>
+            </a:r>
+            <a:r>
+              <a:rPr lang="en-US" sz="1900" dirty="0"/>
+              <a:t>, </a:t>
+            </a:r>
+            <a:r>
+              <a:rPr lang="en-US" sz="1900" dirty="0">
+                <a:latin typeface="Consolas" panose="020B0609020204030204" pitchFamily="49" charset="0"/>
+              </a:rPr>
+              <a:t>Char</a:t>
+            </a:r>
+            <a:r>
+              <a:rPr lang="en-US" sz="1900" dirty="0"/>
+              <a:t>, </a:t>
+            </a:r>
+            <a:r>
+              <a:rPr lang="en-US" sz="1900" dirty="0">
+                <a:latin typeface="Consolas" panose="020B0609020204030204" pitchFamily="49" charset="0"/>
+              </a:rPr>
+              <a:t>Boolean</a:t>
+            </a:r>
+            <a:r>
+              <a:rPr lang="en-US" sz="1900" dirty="0"/>
+              <a:t>, or a string type.  Output is supported only for integers, characters, </a:t>
             </a:r>
             <a:r>
               <a:rPr lang="en-US" sz="1900" dirty="0" err="1"/>
-              <a:t>parameterless</a:t>
+              <a:t>booleans</a:t>
             </a:r>
             <a:r>
               <a:rPr lang="en-US" sz="1900" dirty="0"/>
-              <a:t> procedure named </a:t>
-            </a:r>
-            <a:r>
-              <a:rPr lang="en-US" sz="1900" dirty="0">
-                <a:latin typeface="Consolas" panose="020B0609020204030204" pitchFamily="49" charset="0"/>
-              </a:rPr>
-              <a:t>main()</a:t>
-            </a:r>
-            <a:r>
-              <a:rPr lang="en-US" sz="1900" dirty="0"/>
-              <a:t>.</a:t>
+              <a:t>, and strings.</a:t>
             </a:r>
           </a:p>
         </p:txBody>
@@ -7659,58 +7747,35 @@
           <a:lstStyle/>
           <a:p>
             <a:r>
-              <a:rPr lang="en-US" sz="2200" dirty="0" err="1">
-                <a:latin typeface="Consolas" panose="020B0609020204030204" pitchFamily="49" charset="0"/>
-              </a:rPr>
-              <a:t>OutputStmt</a:t>
-            </a:r>
-            <a:endParaRPr lang="en-US" sz="2200" dirty="0">
-              <a:latin typeface="Consolas" panose="020B0609020204030204" pitchFamily="49" charset="0"/>
-            </a:endParaRPr>
+              <a:rPr lang="en-US" sz="2200" dirty="0">
+                <a:latin typeface="Consolas" panose="020B0609020204030204" pitchFamily="49" charset="0"/>
+              </a:rPr>
+              <a:t>Program</a:t>
+            </a:r>
           </a:p>
           <a:p>
             <a:pPr lvl="1"/>
             <a:r>
               <a:rPr lang="en-US" sz="1900" dirty="0"/>
-              <a:t>Type Rule: Each expression must have type </a:t>
+              <a:t>Miscellaneous Rule: A program must contain a </a:t>
+            </a:r>
+            <a:r>
+              <a:rPr lang="en-US" sz="1900" dirty="0" err="1"/>
+              <a:t>parameterless</a:t>
+            </a:r>
+            <a:r>
+              <a:rPr lang="en-US" sz="1900" dirty="0"/>
+              <a:t> procedure named </a:t>
             </a:r>
             <a:r>
               <a:rPr lang="en-US" sz="1900" dirty="0">
                 <a:latin typeface="Consolas" panose="020B0609020204030204" pitchFamily="49" charset="0"/>
               </a:rPr>
-              <a:t>Integer</a:t>
+              <a:t>main()</a:t>
             </a:r>
             <a:r>
               <a:rPr lang="en-US" sz="1900" dirty="0"/>
-              <a:t>, </a:t>
-            </a:r>
-            <a:r>
-              <a:rPr lang="en-US" sz="1900" dirty="0">
-                <a:latin typeface="Consolas" panose="020B0609020204030204" pitchFamily="49" charset="0"/>
-              </a:rPr>
-              <a:t>Char</a:t>
-            </a:r>
-            <a:r>
-              <a:rPr lang="en-US" sz="1900" dirty="0"/>
-              <a:t>, </a:t>
-            </a:r>
-            <a:r>
-              <a:rPr lang="en-US" sz="1900" dirty="0">
-                <a:latin typeface="Consolas" panose="020B0609020204030204" pitchFamily="49" charset="0"/>
-              </a:rPr>
-              <a:t>Boolean</a:t>
-            </a:r>
-            <a:r>
-              <a:rPr lang="en-US" sz="1900" dirty="0"/>
-              <a:t>, or a string type.  Output is supported only for integers, characters, </a:t>
-            </a:r>
-            <a:r>
-              <a:rPr lang="en-US" sz="1900" dirty="0" err="1"/>
-              <a:t>booleans</a:t>
-            </a:r>
-            <a:r>
-              <a:rPr lang="en-US" sz="1900" dirty="0"/>
-              <a:t>, and strings.</a:t>
+              <a:t>.</a:t>
             </a:r>
           </a:p>
           <a:p>
@@ -8164,32 +8229,70 @@
           <a:p>
             <a:pPr lvl="2"/>
             <a:r>
-              <a:rPr lang="en-US" dirty="0"/>
-              <a:t>For CPRL/0, method </a:t>
-            </a:r>
-            <a:r>
-              <a:rPr lang="en-US" dirty="0" err="1"/>
+              <a:rPr lang="en-US" sz="1750" dirty="0"/>
+              <a:t>For CPRL/</a:t>
+            </a:r>
+            <a:r>
+              <a:rPr lang="en-US" sz="1750" dirty="0">
+                <a:latin typeface="Consolas" panose="020B0609020204030204" pitchFamily="49" charset="0"/>
+              </a:rPr>
+              <a:t>0</a:t>
+            </a:r>
+            <a:r>
+              <a:rPr lang="en-US" sz="1750" dirty="0"/>
+              <a:t>, method </a:t>
+            </a:r>
+            <a:r>
+              <a:rPr lang="en-US" sz="1750" dirty="0" err="1">
+                <a:latin typeface="Consolas" panose="020B0609020204030204" pitchFamily="49" charset="0"/>
+              </a:rPr>
               <a:t>matchTypes</a:t>
             </a:r>
             <a:r>
-              <a:rPr lang="en-US" dirty="0"/>
-              <a:t>() in class AST can be used to check for assignment compatibility.  But method </a:t>
-            </a:r>
-            <a:r>
-              <a:rPr lang="en-US" dirty="0" err="1"/>
+              <a:rPr lang="en-US" sz="1750" dirty="0">
+                <a:latin typeface="Consolas" panose="020B0609020204030204" pitchFamily="49" charset="0"/>
+              </a:rPr>
+              <a:t>()</a:t>
+            </a:r>
+            <a:r>
+              <a:rPr lang="en-US" sz="1750" dirty="0"/>
+              <a:t> in class </a:t>
+            </a:r>
+            <a:r>
+              <a:rPr lang="en-US" sz="1750" dirty="0">
+                <a:latin typeface="Consolas" panose="020B0609020204030204" pitchFamily="49" charset="0"/>
+              </a:rPr>
+              <a:t>AST</a:t>
+            </a:r>
+            <a:r>
+              <a:rPr lang="en-US" sz="1750" dirty="0"/>
+              <a:t> can be used to check for assignment compatibility.  But method </a:t>
+            </a:r>
+            <a:r>
+              <a:rPr lang="en-US" sz="1750" dirty="0" err="1">
+                <a:latin typeface="Consolas" panose="020B0609020204030204" pitchFamily="49" charset="0"/>
+              </a:rPr>
               <a:t>checkConstraints</a:t>
             </a:r>
             <a:r>
-              <a:rPr lang="en-US" dirty="0"/>
-              <a:t>() becomes complicated when composite types are considered, especially since composite types can be nested. We will revisit type rules for class </a:t>
-            </a:r>
-            <a:r>
-              <a:rPr lang="en-US" dirty="0" err="1"/>
+              <a:rPr lang="en-US" sz="1750" dirty="0">
+                <a:latin typeface="Consolas" panose="020B0609020204030204" pitchFamily="49" charset="0"/>
+              </a:rPr>
+              <a:t>()</a:t>
+            </a:r>
+            <a:r>
+              <a:rPr lang="en-US" sz="1750" dirty="0"/>
+              <a:t> becomes complicated when composite types are considered, especially since composite types can be nested. We will revisit type rules for class </a:t>
+            </a:r>
+            <a:r>
+              <a:rPr lang="en-US" sz="1750" dirty="0" err="1">
+                <a:latin typeface="Consolas" panose="020B0609020204030204" pitchFamily="49" charset="0"/>
+              </a:rPr>
               <a:t>SingleVarDecl</a:t>
             </a:r>
             <a:r>
-              <a:rPr lang="en-US" dirty="0"/>
-              <a:t> in chapters 14, 15, and 16.</a:t>
+              <a:rPr lang="en-US" sz="1750" dirty="0"/>
+              <a:t> in future chapters.</a:t>
             </a:r>
           </a:p>
         </p:txBody>
@@ -9787,7 +9890,17 @@
             </a:r>
             <a:r>
               <a:rPr lang="en-US" dirty="0"/>
-              <a:t> and emit() are complicated by the fact that a variable can be followed by one or more selector expressions.</a:t>
+              <a:t> and </a:t>
+            </a:r>
+            <a:r>
+              <a:rPr lang="en-US" dirty="0">
+                <a:latin typeface="Consolas" panose="020B0609020204030204" pitchFamily="49" charset="0"/>
+              </a:rPr>
+              <a:t>emit()</a:t>
+            </a:r>
+            <a:r>
+              <a:rPr lang="en-US" dirty="0"/>
+              <a:t> are complicated by the fact that a variable can be followed by one or more selector expressions.</a:t>
             </a:r>
           </a:p>
           <a:p>

</xml_diff>